<commit_message>
update products and QGIS
</commit_message>
<xml_diff>
--- a/automatic docx/formato_advertencia.pptx
+++ b/automatic docx/formato_advertencia.pptx
@@ -5,10 +5,11 @@
     <p:sldMasterId id="2147483648" r:id="rId1"/>
   </p:sldMasterIdLst>
   <p:notesMasterIdLst>
-    <p:notesMasterId r:id="rId3"/>
+    <p:notesMasterId r:id="rId4"/>
   </p:notesMasterIdLst>
   <p:sldIdLst>
-    <p:sldId id="387" r:id="rId2"/>
+    <p:sldId id="388" r:id="rId2"/>
+    <p:sldId id="387" r:id="rId3"/>
   </p:sldIdLst>
   <p:sldSz cx="12192000" cy="6858000"/>
   <p:notesSz cx="6858000" cy="9144000"/>
@@ -197,7 +198,7 @@
           <a:p>
             <a:fld id="{DBCE3559-6017-4EA7-9FB2-EFF1484BA4AA}" type="datetimeFigureOut">
               <a:rPr lang="es-UY" smtClean="0"/>
-              <a:t>21/5/2026</a:t>
+              <a:t>20/7/2026</a:t>
             </a:fld>
             <a:endParaRPr lang="es-UY"/>
           </a:p>
@@ -1250,6 +1251,496 @@
           </p:nvPr>
         </p:nvPicPr>
         <p:blipFill>
+          <a:blip r:embed="rId2">
+            <a:extLst>
+              <a:ext uri="{28A0092B-C50C-407E-A947-70E740481C1C}">
+                <a14:useLocalDpi xmlns:a14="http://schemas.microsoft.com/office/drawing/2010/main" val="0"/>
+              </a:ext>
+            </a:extLst>
+          </a:blip>
+          <a:srcRect/>
+          <a:stretch/>
+        </p:blipFill>
+        <p:spPr>
+          <a:xfrm>
+            <a:off x="130175" y="855708"/>
+            <a:ext cx="5889625" cy="5302159"/>
+          </a:xfrm>
+          <a:prstGeom prst="rect">
+            <a:avLst/>
+          </a:prstGeom>
+        </p:spPr>
+      </p:pic>
+      <p:sp>
+        <p:nvSpPr>
+          <p:cNvPr id="9" name="Content Placeholder 8">
+            <a:extLst>
+              <a:ext uri="{FF2B5EF4-FFF2-40B4-BE49-F238E27FC236}">
+                <a16:creationId xmlns:a16="http://schemas.microsoft.com/office/drawing/2014/main" id="{840DFAF7-B1B0-17C5-C31F-0CBD5A7F623A}"/>
+              </a:ext>
+            </a:extLst>
+          </p:cNvPr>
+          <p:cNvSpPr>
+            <a:spLocks noGrp="1"/>
+          </p:cNvSpPr>
+          <p:nvPr>
+            <p:ph sz="half" idx="2"/>
+          </p:nvPr>
+        </p:nvSpPr>
+        <p:spPr>
+          <a:xfrm>
+            <a:off x="6019800" y="776376"/>
+            <a:ext cx="6071846" cy="5460519"/>
+          </a:xfrm>
+        </p:spPr>
+        <p:txBody>
+          <a:bodyPr wrap="square" lIns="91440" tIns="0" rIns="91440" bIns="0" anchor="ctr">
+            <a:normAutofit/>
+          </a:bodyPr>
+          <a:lstStyle/>
+          <a:p>
+            <a:pPr algn="just">
+              <a:lnSpc>
+                <a:spcPct val="110000"/>
+              </a:lnSpc>
+              <a:spcBef>
+                <a:spcPts val="600"/>
+              </a:spcBef>
+              <a:spcAft>
+                <a:spcPts val="600"/>
+              </a:spcAft>
+              <a:buClr>
+                <a:srgbClr val="25418E"/>
+              </a:buClr>
+              <a:buSzPct val="200000"/>
+            </a:pPr>
+            <a:r>
+              <a:rPr lang="es-UY" sz="1500" dirty="0">
+                <a:solidFill>
+                  <a:schemeClr val="tx1"/>
+                </a:solidFill>
+              </a:rPr>
+              <a:t>Acumulados de </a:t>
+            </a:r>
+            <a:r>
+              <a:rPr lang="es-UY" sz="1500" b="1" dirty="0">
+                <a:solidFill>
+                  <a:schemeClr val="tx1"/>
+                </a:solidFill>
+              </a:rPr>
+              <a:t>lluvia</a:t>
+            </a:r>
+            <a:r>
+              <a:rPr lang="es-UY" sz="1500" dirty="0">
+                <a:solidFill>
+                  <a:schemeClr val="tx1"/>
+                </a:solidFill>
+              </a:rPr>
+              <a:t> que rondan entre </a:t>
+            </a:r>
+            <a:r>
+              <a:rPr lang="es-UY" sz="1500" b="1" dirty="0">
+                <a:solidFill>
+                  <a:schemeClr val="tx1"/>
+                </a:solidFill>
+              </a:rPr>
+              <a:t>25 a 75 mm </a:t>
+            </a:r>
+            <a:r>
+              <a:rPr lang="es-UY" sz="1500" dirty="0">
+                <a:solidFill>
+                  <a:schemeClr val="tx1"/>
+                </a:solidFill>
+              </a:rPr>
+              <a:t>en los últimos dos días (16 y 17 julio) en la </a:t>
+            </a:r>
+            <a:r>
+              <a:rPr lang="es-UY" sz="1500" b="1" dirty="0">
+                <a:solidFill>
+                  <a:schemeClr val="tx1"/>
+                </a:solidFill>
+              </a:rPr>
+              <a:t>zona noreste, este y centro </a:t>
+            </a:r>
+            <a:r>
+              <a:rPr lang="es-UY" sz="1500" dirty="0">
+                <a:solidFill>
+                  <a:schemeClr val="tx1"/>
+                </a:solidFill>
+              </a:rPr>
+              <a:t>del país. </a:t>
+            </a:r>
+          </a:p>
+          <a:p>
+            <a:pPr algn="just">
+              <a:lnSpc>
+                <a:spcPct val="110000"/>
+              </a:lnSpc>
+              <a:spcBef>
+                <a:spcPts val="600"/>
+              </a:spcBef>
+              <a:spcAft>
+                <a:spcPts val="600"/>
+              </a:spcAft>
+              <a:buClr>
+                <a:srgbClr val="25418E"/>
+              </a:buClr>
+              <a:buSzPct val="200000"/>
+            </a:pPr>
+            <a:r>
+              <a:rPr lang="es-UY" sz="1500" dirty="0">
+                <a:solidFill>
+                  <a:schemeClr val="tx1"/>
+                </a:solidFill>
+              </a:rPr>
+              <a:t>Condiciones antecedente de </a:t>
+            </a:r>
+            <a:r>
+              <a:rPr lang="es-UY" sz="1500" b="1" dirty="0">
+                <a:solidFill>
+                  <a:schemeClr val="tx1"/>
+                </a:solidFill>
+              </a:rPr>
+              <a:t>humedad de suelo </a:t>
+            </a:r>
+            <a:r>
+              <a:rPr lang="es-UY" sz="1500" dirty="0">
+                <a:solidFill>
+                  <a:schemeClr val="tx1"/>
+                </a:solidFill>
+              </a:rPr>
+              <a:t>en el rango por </a:t>
+            </a:r>
+            <a:r>
+              <a:rPr lang="es-UY" sz="1500" b="1" dirty="0">
+                <a:solidFill>
+                  <a:schemeClr val="tx1"/>
+                </a:solidFill>
+              </a:rPr>
+              <a:t>debajo de lo normal </a:t>
+            </a:r>
+            <a:r>
+              <a:rPr lang="es-UY" sz="1500" dirty="0">
+                <a:solidFill>
+                  <a:schemeClr val="tx1"/>
+                </a:solidFill>
+              </a:rPr>
+              <a:t>en la zona norte, noreste, este y sur del país. En la zona centro condiciones de humedad dentro del rango normal para la época del año. </a:t>
+            </a:r>
+          </a:p>
+          <a:p>
+            <a:pPr algn="just">
+              <a:lnSpc>
+                <a:spcPct val="110000"/>
+              </a:lnSpc>
+              <a:spcBef>
+                <a:spcPts val="600"/>
+              </a:spcBef>
+              <a:spcAft>
+                <a:spcPts val="600"/>
+              </a:spcAft>
+              <a:buClr>
+                <a:srgbClr val="25418E"/>
+              </a:buClr>
+              <a:buSzPct val="200000"/>
+            </a:pPr>
+            <a:r>
+              <a:rPr lang="es-UY" sz="1500" dirty="0">
+                <a:solidFill>
+                  <a:schemeClr val="tx1"/>
+                </a:solidFill>
+              </a:rPr>
+              <a:t>Hasta la emisión de este informe, se observa un incremento leve del caudal del </a:t>
+            </a:r>
+            <a:r>
+              <a:rPr lang="es-UY" sz="1500" b="1" dirty="0">
+                <a:solidFill>
+                  <a:schemeClr val="tx1"/>
+                </a:solidFill>
+              </a:rPr>
+              <a:t>río Tacuarembó </a:t>
+            </a:r>
+            <a:r>
+              <a:rPr lang="es-UY" sz="1500" dirty="0">
+                <a:solidFill>
+                  <a:schemeClr val="tx1"/>
+                </a:solidFill>
+              </a:rPr>
+              <a:t>en Paso Manuel Diaz. En el resto de sitios monitoreo de la red hidrométrica nacional, </a:t>
+            </a:r>
+            <a:r>
+              <a:rPr lang="es-UY" sz="1500" b="1" u="sng" dirty="0">
+                <a:solidFill>
+                  <a:schemeClr val="tx1"/>
+                </a:solidFill>
+              </a:rPr>
+              <a:t>NO</a:t>
+            </a:r>
+            <a:r>
+              <a:rPr lang="es-UY" sz="1500" dirty="0">
+                <a:solidFill>
+                  <a:schemeClr val="tx1"/>
+                </a:solidFill>
+              </a:rPr>
+              <a:t> se registran incrementos de nivel significativos en los ríos y arroyos.   </a:t>
+            </a:r>
+          </a:p>
+          <a:p>
+            <a:pPr algn="just">
+              <a:lnSpc>
+                <a:spcPct val="110000"/>
+              </a:lnSpc>
+              <a:spcBef>
+                <a:spcPts val="600"/>
+              </a:spcBef>
+              <a:spcAft>
+                <a:spcPts val="600"/>
+              </a:spcAft>
+              <a:buClr>
+                <a:srgbClr val="25418E"/>
+              </a:buClr>
+              <a:buSzPct val="200000"/>
+            </a:pPr>
+            <a:r>
+              <a:rPr lang="es-UY" sz="1500" dirty="0">
+                <a:solidFill>
+                  <a:schemeClr val="tx1"/>
+                </a:solidFill>
+              </a:rPr>
+              <a:t>CTM-Salto Grande reporta vertedero cerrado y que el caudal medio diario evacuado variará entre 6500 y 4000 m</a:t>
+            </a:r>
+            <a:r>
+              <a:rPr lang="es-UY" sz="1500" baseline="30000" dirty="0">
+                <a:solidFill>
+                  <a:schemeClr val="tx1"/>
+                </a:solidFill>
+              </a:rPr>
+              <a:t>3</a:t>
+            </a:r>
+            <a:r>
+              <a:rPr lang="es-UY" sz="1500" dirty="0">
+                <a:solidFill>
+                  <a:schemeClr val="tx1"/>
+                </a:solidFill>
+              </a:rPr>
+              <a:t>/s. Nivel del río </a:t>
+            </a:r>
+          </a:p>
+          <a:p>
+            <a:pPr algn="just">
+              <a:lnSpc>
+                <a:spcPct val="110000"/>
+              </a:lnSpc>
+              <a:spcBef>
+                <a:spcPts val="600"/>
+              </a:spcBef>
+              <a:spcAft>
+                <a:spcPts val="600"/>
+              </a:spcAft>
+              <a:buClr>
+                <a:srgbClr val="25418E"/>
+              </a:buClr>
+              <a:buSzPct val="200000"/>
+            </a:pPr>
+            <a:r>
+              <a:rPr lang="es-UY" sz="1500" dirty="0">
+                <a:solidFill>
+                  <a:schemeClr val="tx1"/>
+                </a:solidFill>
+              </a:rPr>
+              <a:t>UTE reporta que el caudal a evacuar en la represa Constitución variará entre 132 a 405 m</a:t>
+            </a:r>
+            <a:r>
+              <a:rPr lang="es-UY" sz="1500" baseline="30000" dirty="0">
+                <a:solidFill>
+                  <a:schemeClr val="tx1"/>
+                </a:solidFill>
+              </a:rPr>
+              <a:t>3</a:t>
+            </a:r>
+            <a:r>
+              <a:rPr lang="es-UY" sz="1500" dirty="0">
+                <a:solidFill>
+                  <a:schemeClr val="tx1"/>
+                </a:solidFill>
+              </a:rPr>
+              <a:t>/s</a:t>
+            </a:r>
+          </a:p>
+        </p:txBody>
+      </p:sp>
+      <p:sp>
+        <p:nvSpPr>
+          <p:cNvPr id="6" name="Title 5">
+            <a:extLst>
+              <a:ext uri="{FF2B5EF4-FFF2-40B4-BE49-F238E27FC236}">
+                <a16:creationId xmlns:a16="http://schemas.microsoft.com/office/drawing/2014/main" id="{0F739A5B-51D3-512D-3806-36AAFD143109}"/>
+              </a:ext>
+            </a:extLst>
+          </p:cNvPr>
+          <p:cNvSpPr>
+            <a:spLocks noGrp="1"/>
+          </p:cNvSpPr>
+          <p:nvPr>
+            <p:ph type="title" idx="4294967295"/>
+          </p:nvPr>
+        </p:nvSpPr>
+        <p:spPr>
+          <a:xfrm>
+            <a:off x="198407" y="69021"/>
+            <a:ext cx="11879262" cy="412750"/>
+          </a:xfrm>
+          <a:prstGeom prst="rect">
+            <a:avLst/>
+          </a:prstGeom>
+        </p:spPr>
+        <p:txBody>
+          <a:bodyPr>
+            <a:normAutofit fontScale="90000"/>
+          </a:bodyPr>
+          <a:lstStyle/>
+          <a:p>
+            <a:r>
+              <a:rPr lang="es-UY" dirty="0"/>
+              <a:t>Estado hidrológico actual</a:t>
+            </a:r>
+          </a:p>
+        </p:txBody>
+      </p:sp>
+      <p:sp>
+        <p:nvSpPr>
+          <p:cNvPr id="5" name="TextBox 4">
+            <a:extLst>
+              <a:ext uri="{FF2B5EF4-FFF2-40B4-BE49-F238E27FC236}">
+                <a16:creationId xmlns:a16="http://schemas.microsoft.com/office/drawing/2014/main" id="{24B9160D-938E-E970-8AE4-231322607C6A}"/>
+              </a:ext>
+            </a:extLst>
+          </p:cNvPr>
+          <p:cNvSpPr txBox="1"/>
+          <p:nvPr/>
+        </p:nvSpPr>
+        <p:spPr>
+          <a:xfrm>
+            <a:off x="198407" y="438523"/>
+            <a:ext cx="11878573" cy="261610"/>
+          </a:xfrm>
+          <a:prstGeom prst="rect">
+            <a:avLst/>
+          </a:prstGeom>
+          <a:noFill/>
+        </p:spPr>
+        <p:txBody>
+          <a:bodyPr wrap="square">
+            <a:spAutoFit/>
+          </a:bodyPr>
+          <a:lstStyle/>
+          <a:p>
+            <a:r>
+              <a:rPr lang="es-ES" sz="1100" b="1" dirty="0">
+                <a:solidFill>
+                  <a:schemeClr val="bg1"/>
+                </a:solidFill>
+                <a:latin typeface="Arial Nova" panose="020B0504020202020204" pitchFamily="34" charset="0"/>
+              </a:rPr>
+              <a:t>Fecha emisión: Sábado, 18 de julio de 2026 </a:t>
+            </a:r>
+            <a:endParaRPr lang="es-UY" sz="1100" b="1" dirty="0">
+              <a:solidFill>
+                <a:schemeClr val="bg1"/>
+              </a:solidFill>
+              <a:latin typeface="Arial Nova" panose="020B0504020202020204" pitchFamily="34" charset="0"/>
+            </a:endParaRPr>
+          </a:p>
+        </p:txBody>
+      </p:sp>
+      <p:sp>
+        <p:nvSpPr>
+          <p:cNvPr id="3" name="TextBox 2">
+            <a:extLst>
+              <a:ext uri="{FF2B5EF4-FFF2-40B4-BE49-F238E27FC236}">
+                <a16:creationId xmlns:a16="http://schemas.microsoft.com/office/drawing/2014/main" id="{78C0FAE7-2069-3189-49EA-B1179FAA86E3}"/>
+              </a:ext>
+            </a:extLst>
+          </p:cNvPr>
+          <p:cNvSpPr txBox="1"/>
+          <p:nvPr/>
+        </p:nvSpPr>
+        <p:spPr>
+          <a:xfrm>
+            <a:off x="78419" y="6051528"/>
+            <a:ext cx="5889625" cy="261610"/>
+          </a:xfrm>
+          <a:prstGeom prst="rect">
+            <a:avLst/>
+          </a:prstGeom>
+          <a:noFill/>
+        </p:spPr>
+        <p:txBody>
+          <a:bodyPr wrap="square">
+            <a:spAutoFit/>
+          </a:bodyPr>
+          <a:lstStyle/>
+          <a:p>
+            <a:pPr algn="ctr"/>
+            <a:r>
+              <a:rPr lang="es-ES" sz="1100" b="1" dirty="0">
+                <a:latin typeface="Arial Nova" panose="020B0504020202020204" pitchFamily="34" charset="0"/>
+              </a:rPr>
+              <a:t>Periodo: 07:00 horas 16 Julio hasta 07:00 horas 18 Julio 2026</a:t>
+            </a:r>
+            <a:endParaRPr lang="es-UY" sz="1100" b="1" dirty="0">
+              <a:latin typeface="Arial Nova" panose="020B0504020202020204" pitchFamily="34" charset="0"/>
+            </a:endParaRPr>
+          </a:p>
+        </p:txBody>
+      </p:sp>
+    </p:spTree>
+    <p:extLst>
+      <p:ext uri="{BB962C8B-B14F-4D97-AF65-F5344CB8AC3E}">
+        <p14:creationId xmlns:p14="http://schemas.microsoft.com/office/powerpoint/2010/main" val="3989060880"/>
+      </p:ext>
+    </p:extLst>
+  </p:cSld>
+  <p:clrMapOvr>
+    <a:masterClrMapping/>
+  </p:clrMapOvr>
+</p:sld>
+</file>
+
+<file path=ppt/slides/slide2.xml><?xml version="1.0" encoding="utf-8"?>
+<p:sld xmlns:a="http://schemas.openxmlformats.org/drawingml/2006/main" xmlns:r="http://schemas.openxmlformats.org/officeDocument/2006/relationships" xmlns:p="http://schemas.openxmlformats.org/presentationml/2006/main">
+  <p:cSld>
+    <p:spTree>
+      <p:nvGrpSpPr>
+        <p:cNvPr id="1" name=""/>
+        <p:cNvGrpSpPr/>
+        <p:nvPr/>
+      </p:nvGrpSpPr>
+      <p:grpSpPr>
+        <a:xfrm>
+          <a:off x="0" y="0"/>
+          <a:ext cx="0" cy="0"/>
+          <a:chOff x="0" y="0"/>
+          <a:chExt cx="0" cy="0"/>
+        </a:xfrm>
+      </p:grpSpPr>
+      <p:pic>
+        <p:nvPicPr>
+          <p:cNvPr id="20" name="Content Placeholder 19">
+            <a:extLst>
+              <a:ext uri="{FF2B5EF4-FFF2-40B4-BE49-F238E27FC236}">
+                <a16:creationId xmlns:a16="http://schemas.microsoft.com/office/drawing/2014/main" id="{B77062A2-DEAE-A6F7-D596-45CDC493F93C}"/>
+              </a:ext>
+            </a:extLst>
+          </p:cNvPr>
+          <p:cNvPicPr>
+            <a:picLocks noGrp="1" noChangeAspect="1"/>
+          </p:cNvPicPr>
+          <p:nvPr>
+            <p:ph sz="half" idx="1"/>
+          </p:nvPr>
+        </p:nvPicPr>
+        <p:blipFill>
           <a:blip r:embed="rId2"/>
           <a:stretch>
             <a:fillRect/>
@@ -1289,9 +1780,43 @@
         </p:spPr>
         <p:txBody>
           <a:bodyPr wrap="square" lIns="91440" tIns="0" rIns="91440" bIns="0" anchor="ctr">
-            <a:normAutofit/>
+            <a:normAutofit fontScale="92500" lnSpcReduction="10000"/>
           </a:bodyPr>
           <a:lstStyle/>
+          <a:p>
+            <a:pPr marL="0" indent="0" algn="just">
+              <a:lnSpc>
+                <a:spcPct val="110000"/>
+              </a:lnSpc>
+              <a:spcBef>
+                <a:spcPts val="600"/>
+              </a:spcBef>
+              <a:spcAft>
+                <a:spcPts val="600"/>
+              </a:spcAft>
+              <a:buClr>
+                <a:srgbClr val="25418E"/>
+              </a:buClr>
+              <a:buSzPct val="200000"/>
+              <a:buNone/>
+            </a:pPr>
+            <a:r>
+              <a:rPr lang="es-UY" sz="1500" b="1" dirty="0">
+                <a:solidFill>
+                  <a:schemeClr val="bg1"/>
+                </a:solidFill>
+                <a:highlight>
+                  <a:srgbClr val="008000"/>
+                </a:highlight>
+              </a:rPr>
+              <a:t>Vigilancia</a:t>
+            </a:r>
+            <a:endParaRPr lang="es-UY" sz="1500" b="1" dirty="0">
+              <a:solidFill>
+                <a:schemeClr val="bg1"/>
+              </a:solidFill>
+            </a:endParaRPr>
+          </a:p>
           <a:p>
             <a:pPr algn="just">
               <a:lnSpc>
@@ -1309,40 +1834,58 @@
               <a:buSzPct val="200000"/>
             </a:pPr>
             <a:r>
+              <a:rPr lang="es-UY" sz="1500" dirty="0">
+                <a:solidFill>
+                  <a:schemeClr val="tx1"/>
+                </a:solidFill>
+              </a:rPr>
+              <a:t>Se espera que el río aumente su nivel en las próximas horas aunque se mantendría por debajo de la cota de aviso (6.05 m) entre el 28 y 29 octubre 2025. </a:t>
+            </a:r>
+            <a:r>
+              <a:rPr lang="es-ES" sz="1500" dirty="0">
+                <a:solidFill>
+                  <a:schemeClr val="tx1"/>
+                </a:solidFill>
+              </a:rPr>
+              <a:t>La posibilidad de afectación a vivienda (cota seguridad 8.20 m) es baja. </a:t>
+            </a:r>
+          </a:p>
+          <a:p>
+            <a:pPr marL="0" indent="0" algn="just">
+              <a:lnSpc>
+                <a:spcPct val="110000"/>
+              </a:lnSpc>
+              <a:spcBef>
+                <a:spcPts val="600"/>
+              </a:spcBef>
+              <a:spcAft>
+                <a:spcPts val="600"/>
+              </a:spcAft>
+              <a:buClr>
+                <a:srgbClr val="25418E"/>
+              </a:buClr>
+              <a:buSzPct val="200000"/>
+              <a:buNone/>
+            </a:pPr>
+            <a:r>
               <a:rPr lang="es-UY" sz="1500" b="1" dirty="0">
                 <a:solidFill>
-                  <a:schemeClr val="bg1"/>
+                  <a:schemeClr val="tx1"/>
                 </a:solidFill>
                 <a:highlight>
-                  <a:srgbClr val="008000"/>
+                  <a:srgbClr val="FFFF00"/>
                 </a:highlight>
               </a:rPr>
-              <a:t>Vigilancia:</a:t>
-            </a:r>
-            <a:r>
-              <a:rPr lang="es-UY" sz="1500" b="1" dirty="0">
-                <a:solidFill>
-                  <a:schemeClr val="bg1"/>
-                </a:solidFill>
-              </a:rPr>
-              <a:t> </a:t>
-            </a:r>
-            <a:r>
-              <a:rPr lang="es-UY" sz="1500" dirty="0">
-                <a:solidFill>
-                  <a:schemeClr val="tx1"/>
-                </a:solidFill>
-              </a:rPr>
-              <a:t>Se espera que el río aumente su nivel en las próximas horas aunque se mantendría por debajo de la cota de aviso (6.05 m) entre el 28 y 29 octubre 2025. </a:t>
-            </a:r>
-            <a:r>
-              <a:rPr lang="es-ES" sz="1500" dirty="0">
-                <a:solidFill>
-                  <a:schemeClr val="tx1"/>
-                </a:solidFill>
-              </a:rPr>
-              <a:t>La posibilidad de afectación a vivienda (cota seguridad 8.20 m) es baja. </a:t>
-            </a:r>
+              <a:t>Atención</a:t>
+            </a:r>
+            <a:endParaRPr lang="es-UY" sz="1500" b="1" dirty="0">
+              <a:solidFill>
+                <a:schemeClr val="bg1"/>
+              </a:solidFill>
+              <a:highlight>
+                <a:srgbClr val="FFFF00"/>
+              </a:highlight>
+            </a:endParaRPr>
           </a:p>
           <a:p>
             <a:pPr algn="just">
@@ -1361,32 +1904,47 @@
               <a:buSzPct val="200000"/>
             </a:pPr>
             <a:r>
-              <a:rPr lang="es-UY" sz="1500" b="1" dirty="0">
-                <a:solidFill>
-                  <a:schemeClr val="tx1"/>
+              <a:rPr lang="es-UY" sz="1500" dirty="0">
+                <a:solidFill>
+                  <a:schemeClr val="tx1"/>
+                </a:solidFill>
+              </a:rPr>
+              <a:t>Debido a las lluvias registradas, es esperable incrementos de nivel en los ríos y arroyos que aportan al río Uruguay (Río Queguay) en los departamentos de Paysandú y Río Negro. No se descarta algún impacto puntual en dichos departamentos, como por ejemplo: corte de rutas o anegamiento. </a:t>
+            </a:r>
+          </a:p>
+          <a:p>
+            <a:pPr marL="0" indent="0" algn="just">
+              <a:lnSpc>
+                <a:spcPct val="110000"/>
+              </a:lnSpc>
+              <a:spcBef>
+                <a:spcPts val="600"/>
+              </a:spcBef>
+              <a:spcAft>
+                <a:spcPts val="600"/>
+              </a:spcAft>
+              <a:buClr>
+                <a:srgbClr val="25418E"/>
+              </a:buClr>
+              <a:buSzPct val="200000"/>
+              <a:buNone/>
+            </a:pPr>
+            <a:r>
+              <a:rPr lang="es-ES" sz="1500" b="1" dirty="0">
+                <a:solidFill>
+                  <a:schemeClr val="bg1"/>
                 </a:solidFill>
                 <a:highlight>
-                  <a:srgbClr val="FFFF00"/>
+                  <a:srgbClr val="FFC000"/>
                 </a:highlight>
               </a:rPr>
-              <a:t>Atención:</a:t>
-            </a:r>
-            <a:r>
-              <a:rPr lang="es-UY" sz="1500" b="1" dirty="0">
-                <a:solidFill>
-                  <a:schemeClr val="bg1"/>
-                </a:solidFill>
-              </a:rPr>
-              <a:t>  </a:t>
-            </a:r>
-            <a:r>
-              <a:rPr lang="es-UY" sz="1500" dirty="0">
-                <a:solidFill>
-                  <a:schemeClr val="tx1"/>
-                </a:solidFill>
-              </a:rPr>
-              <a:t>Debido a las lluvias registradas, es esperable incrementos de nivel en los ríos y arroyos que aportan al río Uruguay (Río Queguay) en los departamentos de Paysandú y Río Negro. No se descarta algún impacto puntual en dichos departamentos, como por ejemplo: corte de rutas o anegamiento. </a:t>
-            </a:r>
+              <a:t>Preparación</a:t>
+            </a:r>
+            <a:endParaRPr lang="es-ES" sz="1500" b="1" dirty="0">
+              <a:solidFill>
+                <a:schemeClr val="bg1"/>
+              </a:solidFill>
+            </a:endParaRPr>
           </a:p>
           <a:p>
             <a:pPr algn="just">
@@ -1405,25 +1963,6 @@
               <a:buSzPct val="200000"/>
             </a:pPr>
             <a:r>
-              <a:rPr lang="es-ES" sz="1500" b="1" dirty="0">
-                <a:solidFill>
-                  <a:schemeClr val="bg1"/>
-                </a:solidFill>
-                <a:highlight>
-                  <a:srgbClr val="FFC000"/>
-                </a:highlight>
-              </a:rPr>
-              <a:t>Preparación:</a:t>
-            </a:r>
-            <a:r>
-              <a:rPr lang="es-ES" sz="1500" b="1" dirty="0">
-                <a:solidFill>
-                  <a:schemeClr val="bg1"/>
-                </a:solidFill>
-              </a:rPr>
-              <a:t> </a:t>
-            </a:r>
-            <a:r>
               <a:rPr lang="es-ES" sz="1500" dirty="0">
                 <a:solidFill>
                   <a:schemeClr val="tx1"/>
@@ -1436,6 +1975,35 @@
                 <a:schemeClr val="tx1"/>
               </a:solidFill>
             </a:endParaRPr>
+          </a:p>
+          <a:p>
+            <a:pPr marL="0" indent="0" algn="just">
+              <a:lnSpc>
+                <a:spcPct val="110000"/>
+              </a:lnSpc>
+              <a:spcBef>
+                <a:spcPts val="600"/>
+              </a:spcBef>
+              <a:spcAft>
+                <a:spcPts val="600"/>
+              </a:spcAft>
+              <a:buClr>
+                <a:srgbClr val="25418E"/>
+              </a:buClr>
+              <a:buSzPct val="200000"/>
+              <a:buNone/>
+            </a:pPr>
+            <a:r>
+              <a:rPr lang="es-UY" sz="1500" b="1" dirty="0">
+                <a:solidFill>
+                  <a:schemeClr val="bg1"/>
+                </a:solidFill>
+                <a:highlight>
+                  <a:srgbClr val="FF0000"/>
+                </a:highlight>
+              </a:rPr>
+              <a:t>Tomar acción: </a:t>
+            </a:r>
           </a:p>
           <a:p>
             <a:pPr algn="just">
@@ -1453,17 +2021,6 @@
               </a:buClr>
               <a:buSzPct val="200000"/>
             </a:pPr>
-            <a:r>
-              <a:rPr lang="es-UY" sz="1500" b="1" dirty="0">
-                <a:solidFill>
-                  <a:schemeClr val="bg1"/>
-                </a:solidFill>
-                <a:highlight>
-                  <a:srgbClr val="FF0000"/>
-                </a:highlight>
-              </a:rPr>
-              <a:t>Tomar acción: </a:t>
-            </a:r>
             <a:r>
               <a:rPr lang="es-UY" sz="1500" dirty="0">
                 <a:solidFill>

</xml_diff>